<commit_message>
update presentation file for Android 10 AOSP app investigations - Pixel 3 device investigation
</commit_message>
<xml_diff>
--- a/Android10/2_Pixel3_Device_Investigation.pptx
+++ b/Android10/2_Pixel3_Device_Investigation.pptx
@@ -493,7 +493,7 @@
           <a:p>
             <a:fld id="{EE41F6E3-57F9-402E-BDBA-5B2DE11C8530}" type="datetimeFigureOut">
               <a:rPr lang="en-US" smtClean="0"/>
-              <a:t>9/9/2026</a:t>
+              <a:t>9/25/2026</a:t>
             </a:fld>
             <a:endParaRPr lang="en-US"/>
           </a:p>
@@ -5384,7 +5384,7 @@
           <a:p>
             <a:fld id="{4263717A-E3C1-4BED-ABE0-B7069385E023}" type="datetimeFigureOut">
               <a:rPr lang="en-US" smtClean="0"/>
-              <a:t>9/9/2026</a:t>
+              <a:t>9/25/2026</a:t>
             </a:fld>
             <a:endParaRPr lang="en-US"/>
           </a:p>
@@ -5557,7 +5557,7 @@
           <a:p>
             <a:fld id="{4263717A-E3C1-4BED-ABE0-B7069385E023}" type="datetimeFigureOut">
               <a:rPr lang="en-US" smtClean="0"/>
-              <a:t>9/9/2026</a:t>
+              <a:t>9/25/2026</a:t>
             </a:fld>
             <a:endParaRPr lang="en-US"/>
           </a:p>
@@ -5735,7 +5735,7 @@
           <a:p>
             <a:fld id="{4263717A-E3C1-4BED-ABE0-B7069385E023}" type="datetimeFigureOut">
               <a:rPr lang="en-US" smtClean="0"/>
-              <a:t>9/9/2026</a:t>
+              <a:t>9/25/2026</a:t>
             </a:fld>
             <a:endParaRPr lang="en-US"/>
           </a:p>
@@ -5903,7 +5903,7 @@
           <a:p>
             <a:fld id="{4263717A-E3C1-4BED-ABE0-B7069385E023}" type="datetimeFigureOut">
               <a:rPr lang="en-US" smtClean="0"/>
-              <a:t>9/9/2026</a:t>
+              <a:t>9/25/2026</a:t>
             </a:fld>
             <a:endParaRPr lang="en-US"/>
           </a:p>
@@ -6148,7 +6148,7 @@
           <a:p>
             <a:fld id="{4263717A-E3C1-4BED-ABE0-B7069385E023}" type="datetimeFigureOut">
               <a:rPr lang="en-US" smtClean="0"/>
-              <a:t>9/9/2026</a:t>
+              <a:t>9/25/2026</a:t>
             </a:fld>
             <a:endParaRPr lang="en-US"/>
           </a:p>
@@ -6377,7 +6377,7 @@
           <a:p>
             <a:fld id="{4263717A-E3C1-4BED-ABE0-B7069385E023}" type="datetimeFigureOut">
               <a:rPr lang="en-US" smtClean="0"/>
-              <a:t>9/9/2026</a:t>
+              <a:t>9/25/2026</a:t>
             </a:fld>
             <a:endParaRPr lang="en-US"/>
           </a:p>
@@ -6741,7 +6741,7 @@
           <a:p>
             <a:fld id="{4263717A-E3C1-4BED-ABE0-B7069385E023}" type="datetimeFigureOut">
               <a:rPr lang="en-US" smtClean="0"/>
-              <a:t>9/9/2026</a:t>
+              <a:t>9/25/2026</a:t>
             </a:fld>
             <a:endParaRPr lang="en-US"/>
           </a:p>
@@ -6858,7 +6858,7 @@
           <a:p>
             <a:fld id="{4263717A-E3C1-4BED-ABE0-B7069385E023}" type="datetimeFigureOut">
               <a:rPr lang="en-US" smtClean="0"/>
-              <a:t>9/9/2026</a:t>
+              <a:t>9/25/2026</a:t>
             </a:fld>
             <a:endParaRPr lang="en-US"/>
           </a:p>
@@ -6953,7 +6953,7 @@
           <a:p>
             <a:fld id="{4263717A-E3C1-4BED-ABE0-B7069385E023}" type="datetimeFigureOut">
               <a:rPr lang="en-US" smtClean="0"/>
-              <a:t>9/9/2026</a:t>
+              <a:t>9/25/2026</a:t>
             </a:fld>
             <a:endParaRPr lang="en-US"/>
           </a:p>
@@ -7228,7 +7228,7 @@
           <a:p>
             <a:fld id="{4263717A-E3C1-4BED-ABE0-B7069385E023}" type="datetimeFigureOut">
               <a:rPr lang="en-US" smtClean="0"/>
-              <a:t>9/9/2026</a:t>
+              <a:t>9/25/2026</a:t>
             </a:fld>
             <a:endParaRPr lang="en-US"/>
           </a:p>
@@ -7480,7 +7480,7 @@
           <a:p>
             <a:fld id="{4263717A-E3C1-4BED-ABE0-B7069385E023}" type="datetimeFigureOut">
               <a:rPr lang="en-US" smtClean="0"/>
-              <a:t>9/9/2026</a:t>
+              <a:t>9/25/2026</a:t>
             </a:fld>
             <a:endParaRPr lang="en-US"/>
           </a:p>
@@ -7691,7 +7691,7 @@
           <a:p>
             <a:fld id="{4263717A-E3C1-4BED-ABE0-B7069385E023}" type="datetimeFigureOut">
               <a:rPr lang="en-US" smtClean="0"/>
-              <a:t>9/9/2026</a:t>
+              <a:t>9/25/2026</a:t>
             </a:fld>
             <a:endParaRPr lang="en-US"/>
           </a:p>
@@ -8475,7 +8475,7 @@
         <p:spPr>
           <a:xfrm>
             <a:off x="3726180" y="97657"/>
-            <a:ext cx="7551420" cy="2092881"/>
+            <a:ext cx="7551420" cy="1569660"/>
           </a:xfrm>
           <a:prstGeom prst="rect">
             <a:avLst/>
@@ -8522,17 +8522,7 @@
             </a:pPr>
             <a:r>
               <a:rPr lang="en-GB" sz="1600" dirty="0"/>
-              <a:t>The number is printed on the back of your SIM (sometimes there in only the last 13 digits of ICCID)</a:t>
-            </a:r>
-          </a:p>
-          <a:p>
-            <a:pPr marL="742950" lvl="1" indent="-285750">
-              <a:buFont typeface="Arial" panose="020B0604020202020204" pitchFamily="34" charset="0"/>
-              <a:buChar char="•"/>
-            </a:pPr>
-            <a:r>
-              <a:rPr lang="en-GB" sz="1600" dirty="0"/>
-              <a:t>you can also find it in your phone's settings. Read More about ICCID.</a:t>
+              <a:t>The ICCID may be printed on the SIM card and can usually also be retrieved from the phone's settings or SIM information.</a:t>
             </a:r>
           </a:p>
           <a:p>
@@ -8542,14 +8532,8 @@
             </a:pPr>
             <a:r>
               <a:rPr lang="en-GB" sz="1600" dirty="0"/>
-              <a:t>Based on ICCID number you can check your SIM Country and International phone code.</a:t>
-            </a:r>
-          </a:p>
-          <a:p>
-            <a:pPr marL="742950" lvl="1" indent="-285750">
-              <a:buFont typeface="Arial" panose="020B0604020202020204" pitchFamily="34" charset="0"/>
-              <a:buChar char="•"/>
-            </a:pPr>
+              <a:t>The ICCID contains information identifying the telecommunications industry, issuing country/region, and SIM issuer. </a:t>
+            </a:r>
             <a:r>
               <a:rPr lang="en-US" sz="1600" dirty="0"/>
               <a:t>https://www.imei.info/iccid</a:t>

</xml_diff>